<commit_message>
Clarify Week 7 presentation takeaway
</commit_message>
<xml_diff>
--- a/Term 1/Week 7/presentation/Hogweed_Guard_NL_Hackathon_7.pptx
+++ b/Term 1/Week 7/presentation/Hogweed_Guard_NL_Hackathon_7.pptx
@@ -2,14 +2,14 @@
 <file path=ppt/presentation.xml><?xml version="1.0" encoding="utf-8"?>
 <p:presentation xmlns:p="http://schemas.openxmlformats.org/presentationml/2006/main">
   <p:sldMasterIdLst>
-    <p:sldMasterId xmlns:r="http://schemas.openxmlformats.org/officeDocument/2006/relationships" id="2147483648" r:id="R1b3feabdc03646d4"/>
+    <p:sldMasterId xmlns:r="http://schemas.openxmlformats.org/officeDocument/2006/relationships" id="2147483648" r:id="R85e61e6645d14d03"/>
   </p:sldMasterIdLst>
   <p:sldIdLst>
-    <p:sldId xmlns:r="http://schemas.openxmlformats.org/officeDocument/2006/relationships" id="256" r:id="Rd58d1737f3404f9d"/>
-    <p:sldId xmlns:r="http://schemas.openxmlformats.org/officeDocument/2006/relationships" id="257" r:id="R5fb3da4f88234326"/>
-    <p:sldId xmlns:r="http://schemas.openxmlformats.org/officeDocument/2006/relationships" id="258" r:id="R95179cd7996846c6"/>
-    <p:sldId xmlns:r="http://schemas.openxmlformats.org/officeDocument/2006/relationships" id="259" r:id="R7551462cd475469e"/>
-    <p:sldId xmlns:r="http://schemas.openxmlformats.org/officeDocument/2006/relationships" id="260" r:id="R9e39bc74a3ee4a1c"/>
+    <p:sldId xmlns:r="http://schemas.openxmlformats.org/officeDocument/2006/relationships" id="256" r:id="R7ef5580da89f4885"/>
+    <p:sldId xmlns:r="http://schemas.openxmlformats.org/officeDocument/2006/relationships" id="257" r:id="Rf6f07ee0473c40f1"/>
+    <p:sldId xmlns:r="http://schemas.openxmlformats.org/officeDocument/2006/relationships" id="258" r:id="Rdb3832ff86c940a1"/>
+    <p:sldId xmlns:r="http://schemas.openxmlformats.org/officeDocument/2006/relationships" id="259" r:id="Rad39d64255914df2"/>
+    <p:sldId xmlns:r="http://schemas.openxmlformats.org/officeDocument/2006/relationships" id="260" r:id="Ra15fbee342184431"/>
   </p:sldIdLst>
   <p:sldSz cx="12192000" cy="6858000"/>
   <p:notesSz cx="6858000" cy="9144000"/>
@@ -2429,12 +2429,12 @@
   </p:cSld>
   <p:clrMap bg1="lt1" tx1="dk1" bg2="lt2" tx2="dk2" accent1="accent1" accent2="accent2" accent3="accent3" accent4="accent4" accent5="accent5" accent6="accent6" hlink="hlink" folHlink="folHlink"/>
   <p:sldLayoutIdLst>
-    <p:sldLayoutId xmlns:r="http://schemas.openxmlformats.org/officeDocument/2006/relationships" id="2147483649" r:id="Rdd214cf538864710"/>
-    <p:sldLayoutId xmlns:r="http://schemas.openxmlformats.org/officeDocument/2006/relationships" id="2147483650" r:id="R8268d4b8ff154fe2"/>
-    <p:sldLayoutId xmlns:r="http://schemas.openxmlformats.org/officeDocument/2006/relationships" id="2147483651" r:id="R35808e583d5940e9"/>
-    <p:sldLayoutId xmlns:r="http://schemas.openxmlformats.org/officeDocument/2006/relationships" id="2147483652" r:id="Rfe29bdcf143d46d8"/>
-    <p:sldLayoutId xmlns:r="http://schemas.openxmlformats.org/officeDocument/2006/relationships" id="2147483653" r:id="Rc931fe50e8fa44d7"/>
-    <p:sldLayoutId xmlns:r="http://schemas.openxmlformats.org/officeDocument/2006/relationships" id="2147483654" r:id="R141143a9037a451a"/>
+    <p:sldLayoutId xmlns:r="http://schemas.openxmlformats.org/officeDocument/2006/relationships" id="2147483649" r:id="R03b7ccb585a147a2"/>
+    <p:sldLayoutId xmlns:r="http://schemas.openxmlformats.org/officeDocument/2006/relationships" id="2147483650" r:id="R8a7c4a3362644d7f"/>
+    <p:sldLayoutId xmlns:r="http://schemas.openxmlformats.org/officeDocument/2006/relationships" id="2147483651" r:id="Rc8828ee7727e4a3d"/>
+    <p:sldLayoutId xmlns:r="http://schemas.openxmlformats.org/officeDocument/2006/relationships" id="2147483652" r:id="R1d04f7ea63f44e24"/>
+    <p:sldLayoutId xmlns:r="http://schemas.openxmlformats.org/officeDocument/2006/relationships" id="2147483653" r:id="R5d2d5403a2c0499a"/>
+    <p:sldLayoutId xmlns:r="http://schemas.openxmlformats.org/officeDocument/2006/relationships" id="2147483654" r:id="R058e729759e243a1"/>
   </p:sldLayoutIdLst>
   <p:txStyles>
     <p:titleStyle>
@@ -2985,7 +2985,7 @@
           <p:cNvPr id="6" name="">
             <a:extLst xmlns:a="http://schemas.openxmlformats.org/drawingml/2006/main">
               <a:ext uri="{FF2B5EF4-FFF2-40B4-BE49-F238E27FC236}">
-                <a16:creationId xmlns:a16="http://schemas.microsoft.com/office/drawing/2014/main" id="{63833859-6E81-4CEB-99E1-2121E173B81E}"/>
+                <a16:creationId xmlns:a16="http://schemas.microsoft.com/office/drawing/2014/main" id="{35B6A2DF-6E70-4A86-BFCC-A85821F70948}"/>
               </a:ext>
             </a:extLst>
           </p:cNvPr>
@@ -2995,7 +2995,7 @@
           <p:nvPr/>
         </p:nvPicPr>
         <p:blipFill>
-          <a:blip xmlns:r="http://schemas.openxmlformats.org/officeDocument/2006/relationships" xmlns:a="http://schemas.openxmlformats.org/drawingml/2006/main" r:embed="R311f110f45ff49c1"/>
+          <a:blip xmlns:r="http://schemas.openxmlformats.org/officeDocument/2006/relationships" xmlns:a="http://schemas.openxmlformats.org/drawingml/2006/main" r:embed="Rc32d0fae60bf408d"/>
           <a:srcRect xmlns:a="http://schemas.openxmlformats.org/drawingml/2006/main" l="30859" t="0" r="30859" b="0"/>
           <a:stretch xmlns:a="http://schemas.openxmlformats.org/drawingml/2006/main">
             <a:fillRect l="0" t="0" r="0" b="0"/>
@@ -3665,7 +3665,7 @@
                 <a:ea typeface="Verdana"/>
                 <a:cs typeface="Verdana"/>
               </a:rPr>
-              <a:t>The Dutch NVWA warns that people can confuse it with native common hogweed. Nature volunteers need a safe first screening before expert inspection.</a:t>
+              <a:t>The Dutch NVWA warns that people can confuse it with native common hogweed. Intended users are nature volunteers and site managers — not people seeking medical advice or automatic removal decisions.</a:t>
             </a:r>
           </a:p>
         </p:txBody>
@@ -3764,7 +3764,7 @@
           <p:cNvPr id="5" name="">
             <a:extLst xmlns:a="http://schemas.openxmlformats.org/drawingml/2006/main">
               <a:ext uri="{FF2B5EF4-FFF2-40B4-BE49-F238E27FC236}">
-                <a16:creationId xmlns:a16="http://schemas.microsoft.com/office/drawing/2014/main" id="{4EF07952-40C2-4DDC-879F-00C4473E0DFE}"/>
+                <a16:creationId xmlns:a16="http://schemas.microsoft.com/office/drawing/2014/main" id="{CFB3C1DE-DEA7-4EA0-A485-0DF3C30A496B}"/>
               </a:ext>
             </a:extLst>
           </p:cNvPr>
@@ -3774,7 +3774,7 @@
           <p:nvPr/>
         </p:nvPicPr>
         <p:blipFill>
-          <a:blip xmlns:r="http://schemas.openxmlformats.org/officeDocument/2006/relationships" xmlns:a="http://schemas.openxmlformats.org/drawingml/2006/main" r:embed="R9efd37865a264b95"/>
+          <a:blip xmlns:r="http://schemas.openxmlformats.org/officeDocument/2006/relationships" xmlns:a="http://schemas.openxmlformats.org/drawingml/2006/main" r:embed="R4abd1751f2354048"/>
           <a:srcRect xmlns:a="http://schemas.openxmlformats.org/drawingml/2006/main" l="0" t="12350" r="0" b="12350"/>
           <a:stretch xmlns:a="http://schemas.openxmlformats.org/drawingml/2006/main">
             <a:fillRect l="0" t="0" r="0" b="0"/>
@@ -3998,7 +3998,7 @@
           <p:cNvPr id="2" name="">
             <a:extLst xmlns:a="http://schemas.openxmlformats.org/drawingml/2006/main">
               <a:ext uri="{FF2B5EF4-FFF2-40B4-BE49-F238E27FC236}">
-                <a16:creationId xmlns:a16="http://schemas.microsoft.com/office/drawing/2014/main" id="{966433D5-A4EB-4963-B5EA-C1747EDE2841}"/>
+                <a16:creationId xmlns:a16="http://schemas.microsoft.com/office/drawing/2014/main" id="{80308A2C-EC14-4EFD-8E37-CE1EBF7A101E}"/>
               </a:ext>
             </a:extLst>
           </p:cNvPr>
@@ -4008,7 +4008,7 @@
           <p:nvPr/>
         </p:nvPicPr>
         <p:blipFill>
-          <a:blip xmlns:r="http://schemas.openxmlformats.org/officeDocument/2006/relationships" xmlns:a="http://schemas.openxmlformats.org/drawingml/2006/main" r:embed="Rcb461612f90c45fb"/>
+          <a:blip xmlns:r="http://schemas.openxmlformats.org/officeDocument/2006/relationships" xmlns:a="http://schemas.openxmlformats.org/drawingml/2006/main" r:embed="R0678a41dae764ccf"/>
           <a:srcRect xmlns:a="http://schemas.openxmlformats.org/drawingml/2006/main" l="20060" t="0" r="20060" b="0"/>
           <a:stretch xmlns:a="http://schemas.openxmlformats.org/drawingml/2006/main">
             <a:fillRect l="0" t="0" r="0" b="0"/>
@@ -4290,7 +4290,7 @@
           <p:cNvPr id="6" name="">
             <a:extLst xmlns:a="http://schemas.openxmlformats.org/drawingml/2006/main">
               <a:ext uri="{FF2B5EF4-FFF2-40B4-BE49-F238E27FC236}">
-                <a16:creationId xmlns:a16="http://schemas.microsoft.com/office/drawing/2014/main" id="{A77E2ABE-724B-4C8F-BDE3-0BAFECBACF50}"/>
+                <a16:creationId xmlns:a16="http://schemas.microsoft.com/office/drawing/2014/main" id="{C9B9A36A-7EB1-4F5C-8C13-5E28F354BDE4}"/>
               </a:ext>
             </a:extLst>
           </p:cNvPr>
@@ -4300,7 +4300,7 @@
           <p:nvPr/>
         </p:nvPicPr>
         <p:blipFill>
-          <a:blip xmlns:r="http://schemas.openxmlformats.org/officeDocument/2006/relationships" xmlns:a="http://schemas.openxmlformats.org/drawingml/2006/main" r:embed="R87eaba1b7cf5401d"/>
+          <a:blip xmlns:r="http://schemas.openxmlformats.org/officeDocument/2006/relationships" xmlns:a="http://schemas.openxmlformats.org/drawingml/2006/main" r:embed="R67867417aaf443c1"/>
           <a:srcRect xmlns:a="http://schemas.openxmlformats.org/drawingml/2006/main" l="0" t="14773" r="0" b="14773"/>
           <a:stretch xmlns:a="http://schemas.openxmlformats.org/drawingml/2006/main">
             <a:fillRect l="0" t="0" r="0" b="0"/>
@@ -4582,7 +4582,7 @@
           <p:cNvPr id="10" name="">
             <a:extLst xmlns:a="http://schemas.openxmlformats.org/drawingml/2006/main">
               <a:ext uri="{FF2B5EF4-FFF2-40B4-BE49-F238E27FC236}">
-                <a16:creationId xmlns:a16="http://schemas.microsoft.com/office/drawing/2014/main" id="{9E0661D8-DEB0-41C2-8470-43CC86449776}"/>
+                <a16:creationId xmlns:a16="http://schemas.microsoft.com/office/drawing/2014/main" id="{60371B57-FE1A-4D61-A4CE-11BD593074AF}"/>
               </a:ext>
             </a:extLst>
           </p:cNvPr>
@@ -4592,7 +4592,7 @@
           <p:nvPr/>
         </p:nvPicPr>
         <p:blipFill>
-          <a:blip xmlns:r="http://schemas.openxmlformats.org/officeDocument/2006/relationships" xmlns:a="http://schemas.openxmlformats.org/drawingml/2006/main" r:embed="R8178a86fdc5e4e65"/>
+          <a:blip xmlns:r="http://schemas.openxmlformats.org/officeDocument/2006/relationships" xmlns:a="http://schemas.openxmlformats.org/drawingml/2006/main" r:embed="R73107f17526a4521"/>
           <a:srcRect xmlns:a="http://schemas.openxmlformats.org/drawingml/2006/main" l="20060" t="0" r="20060" b="0"/>
           <a:stretch xmlns:a="http://schemas.openxmlformats.org/drawingml/2006/main">
             <a:fillRect l="0" t="0" r="0" b="0"/>
@@ -5164,7 +5164,7 @@
           <p:cNvPr id="2" name="">
             <a:extLst xmlns:a="http://schemas.openxmlformats.org/drawingml/2006/main">
               <a:ext uri="{FF2B5EF4-FFF2-40B4-BE49-F238E27FC236}">
-                <a16:creationId xmlns:a16="http://schemas.microsoft.com/office/drawing/2014/main" id="{A59D1FF7-A819-4F0E-AA18-81AAC42F3678}"/>
+                <a16:creationId xmlns:a16="http://schemas.microsoft.com/office/drawing/2014/main" id="{9310642B-DF29-4BC3-AF2B-47CC525C1771}"/>
               </a:ext>
             </a:extLst>
           </p:cNvPr>
@@ -5174,7 +5174,7 @@
           <p:nvPr/>
         </p:nvPicPr>
         <p:blipFill>
-          <a:blip xmlns:r="http://schemas.openxmlformats.org/officeDocument/2006/relationships" xmlns:a="http://schemas.openxmlformats.org/drawingml/2006/main" r:embed="R7b9f815b597f4d4a"/>
+          <a:blip xmlns:r="http://schemas.openxmlformats.org/officeDocument/2006/relationships" xmlns:a="http://schemas.openxmlformats.org/drawingml/2006/main" r:embed="Rc13b9807ecd34feb"/>
           <a:stretch xmlns:a="http://schemas.openxmlformats.org/drawingml/2006/main"/>
         </p:blipFill>
         <p:spPr>
@@ -7256,7 +7256,7 @@
                 <a:ea typeface="Verdana"/>
                 <a:cs typeface="Verdana"/>
               </a:rPr>
-              <a:t>The app withholds scores below 65%, never recommends removal, and requires expert confirmation.</a:t>
+              <a:t>What I learned: held-out testing exposed important errors, so the app withholds scores below 65% and requires expert confirmation.</a:t>
             </a:r>
           </a:p>
         </p:txBody>
@@ -7266,7 +7266,7 @@
           <p:cNvPr id="9" name="">
             <a:extLst xmlns:a="http://schemas.openxmlformats.org/drawingml/2006/main">
               <a:ext uri="{FF2B5EF4-FFF2-40B4-BE49-F238E27FC236}">
-                <a16:creationId xmlns:a16="http://schemas.microsoft.com/office/drawing/2014/main" id="{8DE927D7-46F1-4DC6-AF3E-B8AEAAD37AC8}"/>
+                <a16:creationId xmlns:a16="http://schemas.microsoft.com/office/drawing/2014/main" id="{40B20C38-1048-441C-807A-911E25FB71C0}"/>
               </a:ext>
             </a:extLst>
           </p:cNvPr>
@@ -7276,7 +7276,7 @@
           <p:nvPr/>
         </p:nvPicPr>
         <p:blipFill>
-          <a:blip xmlns:r="http://schemas.openxmlformats.org/officeDocument/2006/relationships" xmlns:a="http://schemas.openxmlformats.org/drawingml/2006/main" r:embed="R17101aac6e444471"/>
+          <a:blip xmlns:r="http://schemas.openxmlformats.org/officeDocument/2006/relationships" xmlns:a="http://schemas.openxmlformats.org/drawingml/2006/main" r:embed="Rd11fdcc8057f4145"/>
           <a:stretch xmlns:a="http://schemas.openxmlformats.org/drawingml/2006/main"/>
         </p:blipFill>
         <p:spPr>

</xml_diff>